<commit_message>
Add member emails to report cover and title slide, rebuild report, slides and viva sheet, add annotated demo screenshot
</commit_message>
<xml_diff>
--- a/deliverables/IR_Group13_CaseHOLD_Slides.pptx
+++ b/deliverables/IR_Group13_CaseHOLD_Slides.pptx
@@ -4913,7 +4913,7 @@
         <p:spPr>
           <a:xfrm>
             <a:off x="914400" y="4206240"/>
-            <a:ext cx="10058400" cy="1463040"/>
+            <a:ext cx="10515600" cy="1463040"/>
           </a:xfrm>
           <a:prstGeom prst="rect">
             <a:avLst/>
@@ -4956,6 +4956,15 @@
               </a:rPr>
               <a:t>Vaibhav Bansal (23FE10CSE00333)</a:t>
             </a:r>
+            <a:r>
+              <a:rPr sz="1800" b="0">
+                <a:solidFill>
+                  <a:srgbClr val="595959"/>
+                </a:solidFill>
+                <a:latin typeface="Calibri"/>
+              </a:rPr>
+              <a:t>    VAIBHAV.23FE10CSE00333@muj.manipal.edu</a:t>
+            </a:r>
           </a:p>
           <a:p>
             <a:pPr algn="l">
@@ -4971,6 +4980,15 @@
                 <a:latin typeface="Calibri"/>
               </a:rPr>
               <a:t>Pranav Joshi (23FE10CSE00701)</a:t>
+            </a:r>
+            <a:r>
+              <a:rPr sz="1800" b="0">
+                <a:solidFill>
+                  <a:srgbClr val="595959"/>
+                </a:solidFill>
+                <a:latin typeface="Calibri"/>
+              </a:rPr>
+              <a:t>    Pranav.23FE10CSE00701@muj.manipal.edu</a:t>
             </a:r>
           </a:p>
           <a:p>

</xml_diff>